<commit_message>
Add Top 10 activation timing boxplots
</commit_message>
<xml_diff>
--- a/MODEL DIFFS.pptx
+++ b/MODEL DIFFS.pptx
@@ -29,6 +29,7 @@
     <p:sldId id="274" r:id="rId25"/>
     <p:sldId id="275" r:id="rId26"/>
     <p:sldId id="276" r:id="rId27"/>
+    <p:sldId id="277" r:id="rId28"/>
   </p:sldIdLst>
   <p:sldSz cy="6858000" cx="12191675"/>
   <p:notesSz cx="6858000" cy="9144000"/>
@@ -28020,6 +28021,438 @@
 </p:sld>
 </file>
 
+<file path=ppt/slides/slide22.xml><?xml version="1.0" encoding="utf-8"?>
+<p:sld xmlns:a="http://schemas.openxmlformats.org/drawingml/2006/main" xmlns:p="http://schemas.openxmlformats.org/presentationml/2006/main" xmlns:r="http://schemas.openxmlformats.org/officeDocument/2006/relationships">
+  <p:cSld>
+    <p:spTree>
+      <p:nvGrpSpPr>
+        <p:cNvPr id="1" name=""/>
+        <p:cNvGrpSpPr/>
+        <p:nvPr/>
+      </p:nvGrpSpPr>
+      <p:grpSpPr/>
+      <p:sp>
+        <p:nvSpPr>
+          <p:cNvPr id="3" name="Rectangle 2"/>
+          <p:cNvSpPr/>
+          <p:nvPr/>
+        </p:nvSpPr>
+        <p:spPr>
+          <a:xfrm>
+            <a:off x="0" y="0"/>
+            <a:ext cx="12191675" cy="6858000"/>
+          </a:xfrm>
+          <a:prstGeom prst="rect">
+            <a:avLst/>
+          </a:prstGeom>
+          <a:solidFill>
+            <a:srgbClr val="F8FAFC"/>
+          </a:solidFill>
+          <a:ln>
+            <a:noFill/>
+          </a:ln>
+        </p:spPr>
+        <p:style>
+          <a:lnRef idx="1">
+            <a:schemeClr val="accent1"/>
+          </a:lnRef>
+          <a:fillRef idx="3">
+            <a:schemeClr val="accent1"/>
+          </a:fillRef>
+          <a:effectRef idx="2">
+            <a:schemeClr val="accent1"/>
+          </a:effectRef>
+          <a:fontRef idx="minor">
+            <a:schemeClr val="lt1"/>
+          </a:fontRef>
+        </p:style>
+        <p:txBody>
+          <a:bodyPr rtlCol="0" anchor="ctr"/>
+          <a:lstStyle/>
+          <a:p>
+            <a:pPr algn="ctr"/>
+          </a:p>
+        </p:txBody>
+      </p:sp>
+      <p:sp>
+        <p:nvSpPr>
+          <p:cNvPr id="2" name="Title 1"/>
+          <p:cNvSpPr>
+            <a:spLocks noGrp="1"/>
+          </p:cNvSpPr>
+          <p:nvPr>
+            <p:ph type="title"/>
+          </p:nvPr>
+        </p:nvSpPr>
+        <p:spPr/>
+        <p:txBody>
+          <a:bodyPr/>
+          <a:lstStyle/>
+          <a:p/>
+        </p:txBody>
+      </p:sp>
+      <p:sp>
+        <p:nvSpPr>
+          <p:cNvPr id="4" name="TextBox 3"/>
+          <p:cNvSpPr txBox="1"/>
+          <p:nvPr/>
+        </p:nvSpPr>
+        <p:spPr>
+          <a:xfrm>
+            <a:off x="594360" y="274320"/>
+            <a:ext cx="10972800" cy="228600"/>
+          </a:xfrm>
+          <a:prstGeom prst="rect">
+            <a:avLst/>
+          </a:prstGeom>
+          <a:noFill/>
+        </p:spPr>
+        <p:txBody>
+          <a:bodyPr wrap="none" lIns="27432">
+            <a:spAutoFit/>
+          </a:bodyPr>
+          <a:lstStyle/>
+          <a:p>
+            <a:pPr algn="l"/>
+            <a:r>
+              <a:rPr sz="1000" b="1">
+                <a:solidFill>
+                  <a:srgbClr val="2563EB"/>
+                </a:solidFill>
+                <a:latin typeface="Aptos"/>
+              </a:rPr>
+              <a:t>TIMING DISTRIBUTION</a:t>
+            </a:r>
+          </a:p>
+        </p:txBody>
+      </p:sp>
+      <p:sp>
+        <p:nvSpPr>
+          <p:cNvPr id="5" name="TextBox 4"/>
+          <p:cNvSpPr txBox="1"/>
+          <p:nvPr/>
+        </p:nvSpPr>
+        <p:spPr>
+          <a:xfrm>
+            <a:off x="594360" y="640080"/>
+            <a:ext cx="10972800" cy="594360"/>
+          </a:xfrm>
+          <a:prstGeom prst="rect">
+            <a:avLst/>
+          </a:prstGeom>
+          <a:noFill/>
+        </p:spPr>
+        <p:txBody>
+          <a:bodyPr wrap="none" lIns="27432">
+            <a:spAutoFit/>
+          </a:bodyPr>
+          <a:lstStyle/>
+          <a:p>
+            <a:pPr algn="l"/>
+            <a:r>
+              <a:rPr sz="2700" b="1">
+                <a:solidFill>
+                  <a:srgbClr val="111827"/>
+                </a:solidFill>
+                <a:latin typeface="Aptos"/>
+              </a:rPr>
+              <a:t>Boxplots preserve task-level dispersion across the Top 10</a:t>
+            </a:r>
+          </a:p>
+        </p:txBody>
+      </p:sp>
+      <p:pic>
+        <p:nvPicPr>
+          <p:cNvPr id="6" name="Picture 5" descr="top10_first_activation_boxplots.png"/>
+          <p:cNvPicPr>
+            <a:picLocks noChangeAspect="1"/>
+          </p:cNvPicPr>
+          <p:nvPr/>
+        </p:nvPicPr>
+        <p:blipFill>
+          <a:blip r:embed="rId2"/>
+          <a:stretch>
+            <a:fillRect/>
+          </a:stretch>
+        </p:blipFill>
+        <p:spPr>
+          <a:xfrm>
+            <a:off x="502920" y="1261872"/>
+            <a:ext cx="7955279" cy="4419599"/>
+          </a:xfrm>
+          <a:prstGeom prst="rect">
+            <a:avLst/>
+          </a:prstGeom>
+        </p:spPr>
+      </p:pic>
+      <p:sp>
+        <p:nvSpPr>
+          <p:cNvPr id="7" name="Rounded Rectangle 6"/>
+          <p:cNvSpPr/>
+          <p:nvPr/>
+        </p:nvSpPr>
+        <p:spPr>
+          <a:xfrm>
+            <a:off x="8732520" y="1417320"/>
+            <a:ext cx="2560320" cy="4434840"/>
+          </a:xfrm>
+          <a:prstGeom prst="roundRect">
+            <a:avLst/>
+          </a:prstGeom>
+          <a:solidFill>
+            <a:srgbClr val="FFF7ED"/>
+          </a:solidFill>
+          <a:ln>
+            <a:solidFill>
+              <a:srgbClr val="FDBA74"/>
+            </a:solidFill>
+          </a:ln>
+        </p:spPr>
+        <p:style>
+          <a:lnRef idx="1">
+            <a:schemeClr val="accent1"/>
+          </a:lnRef>
+          <a:fillRef idx="3">
+            <a:schemeClr val="accent1"/>
+          </a:fillRef>
+          <a:effectRef idx="2">
+            <a:schemeClr val="accent1"/>
+          </a:effectRef>
+          <a:fontRef idx="minor">
+            <a:schemeClr val="lt1"/>
+          </a:fontRef>
+        </p:style>
+        <p:txBody>
+          <a:bodyPr rtlCol="0" anchor="ctr"/>
+          <a:lstStyle/>
+          <a:p>
+            <a:pPr algn="ctr"/>
+          </a:p>
+        </p:txBody>
+      </p:sp>
+      <p:sp>
+        <p:nvSpPr>
+          <p:cNvPr id="8" name="TextBox 7"/>
+          <p:cNvSpPr txBox="1"/>
+          <p:nvPr/>
+        </p:nvSpPr>
+        <p:spPr>
+          <a:xfrm>
+            <a:off x="9034272" y="1737360"/>
+            <a:ext cx="1965960" cy="274320"/>
+          </a:xfrm>
+          <a:prstGeom prst="rect">
+            <a:avLst/>
+          </a:prstGeom>
+          <a:noFill/>
+        </p:spPr>
+        <p:txBody>
+          <a:bodyPr wrap="none" lIns="27432">
+            <a:spAutoFit/>
+          </a:bodyPr>
+          <a:lstStyle/>
+          <a:p>
+            <a:pPr algn="l"/>
+            <a:r>
+              <a:rPr sz="1400" b="1">
+                <a:solidFill>
+                  <a:srgbClr val="F59E0B"/>
+                </a:solidFill>
+                <a:latin typeface="Aptos"/>
+              </a:rPr>
+              <a:t>HOW TO READ</a:t>
+            </a:r>
+          </a:p>
+        </p:txBody>
+      </p:sp>
+      <p:sp>
+        <p:nvSpPr>
+          <p:cNvPr id="9" name="TextBox 8"/>
+          <p:cNvSpPr txBox="1"/>
+          <p:nvPr/>
+        </p:nvSpPr>
+        <p:spPr>
+          <a:xfrm>
+            <a:off x="9034272" y="2240280"/>
+            <a:ext cx="1965960" cy="2468880"/>
+          </a:xfrm>
+          <a:prstGeom prst="rect">
+            <a:avLst/>
+          </a:prstGeom>
+          <a:noFill/>
+        </p:spPr>
+        <p:txBody>
+          <a:bodyPr wrap="none" lIns="27432">
+            <a:spAutoFit/>
+          </a:bodyPr>
+          <a:lstStyle/>
+          <a:p>
+            <a:pPr algn="l"/>
+            <a:r>
+              <a:rPr sz="1300" b="0">
+                <a:solidFill>
+                  <a:srgbClr val="172033"/>
+                </a:solidFill>
+                <a:latin typeface="Aptos"/>
+              </a:rPr>
+              <a:t>Box: middle 50% of tasks
+Red line: median
+Whiskers: values within 1.5x IQR
+Outliers hidden for readability
+Only active contamination cases</a:t>
+            </a:r>
+          </a:p>
+        </p:txBody>
+      </p:sp>
+      <p:sp>
+        <p:nvSpPr>
+          <p:cNvPr id="10" name="TextBox 9"/>
+          <p:cNvSpPr txBox="1"/>
+          <p:nvPr/>
+        </p:nvSpPr>
+        <p:spPr>
+          <a:xfrm>
+            <a:off x="9034272" y="4983480"/>
+            <a:ext cx="1965960" cy="548640"/>
+          </a:xfrm>
+          <a:prstGeom prst="rect">
+            <a:avLst/>
+          </a:prstGeom>
+          <a:noFill/>
+        </p:spPr>
+        <p:txBody>
+          <a:bodyPr wrap="none" lIns="27432">
+            <a:spAutoFit/>
+          </a:bodyPr>
+          <a:lstStyle/>
+          <a:p>
+            <a:pPr algn="ctr"/>
+            <a:r>
+              <a:rPr sz="1400" b="1">
+                <a:solidFill>
+                  <a:srgbClr val="2563EB"/>
+                </a:solidFill>
+                <a:latin typeface="Aptos"/>
+              </a:rPr>
+              <a:t>5422 median: 39.2%
+n = 119/119 active</a:t>
+            </a:r>
+          </a:p>
+        </p:txBody>
+      </p:sp>
+      <p:sp>
+        <p:nvSpPr>
+          <p:cNvPr id="11" name="TextBox 10"/>
+          <p:cNvSpPr txBox="1"/>
+          <p:nvPr/>
+        </p:nvSpPr>
+        <p:spPr>
+          <a:xfrm>
+            <a:off x="914400" y="6144768"/>
+            <a:ext cx="10241280" cy="274320"/>
+          </a:xfrm>
+          <a:prstGeom prst="rect">
+            <a:avLst/>
+          </a:prstGeom>
+          <a:noFill/>
+        </p:spPr>
+        <p:txBody>
+          <a:bodyPr wrap="none" lIns="27432">
+            <a:spAutoFit/>
+          </a:bodyPr>
+          <a:lstStyle/>
+          <a:p>
+            <a:pPr algn="ctr"/>
+            <a:r>
+              <a:rPr sz="1100" b="1">
+                <a:solidFill>
+                  <a:srgbClr val="EF4444"/>
+                </a:solidFill>
+                <a:latin typeface="Aptos"/>
+              </a:rPr>
+              <a:t>Position is measured over extraction-v4 evaluated-code tokens; it does not establish precedence to the first test marker.</a:t>
+            </a:r>
+          </a:p>
+        </p:txBody>
+      </p:sp>
+      <p:sp>
+        <p:nvSpPr>
+          <p:cNvPr id="12" name="TextBox 11"/>
+          <p:cNvSpPr txBox="1"/>
+          <p:nvPr/>
+        </p:nvSpPr>
+        <p:spPr>
+          <a:xfrm>
+            <a:off x="594360" y="6547104"/>
+            <a:ext cx="6400800" cy="164592"/>
+          </a:xfrm>
+          <a:prstGeom prst="rect">
+            <a:avLst/>
+          </a:prstGeom>
+          <a:noFill/>
+        </p:spPr>
+        <p:txBody>
+          <a:bodyPr wrap="none" lIns="27432">
+            <a:spAutoFit/>
+          </a:bodyPr>
+          <a:lstStyle/>
+          <a:p>
+            <a:pPr algn="l"/>
+            <a:r>
+              <a:rPr sz="800" b="0">
+                <a:solidFill>
+                  <a:srgbClr val="94A3B8"/>
+                </a:solidFill>
+                <a:latin typeface="Aptos"/>
+              </a:rPr>
+              <a:t>DSTK100 - exploratory improvement-feature audit</a:t>
+            </a:r>
+          </a:p>
+        </p:txBody>
+      </p:sp>
+      <p:sp>
+        <p:nvSpPr>
+          <p:cNvPr id="13" name="TextBox 12"/>
+          <p:cNvSpPr txBox="1"/>
+          <p:nvPr/>
+        </p:nvSpPr>
+        <p:spPr>
+          <a:xfrm>
+            <a:off x="11155680" y="6510528"/>
+            <a:ext cx="365760" cy="182880"/>
+          </a:xfrm>
+          <a:prstGeom prst="rect">
+            <a:avLst/>
+          </a:prstGeom>
+          <a:noFill/>
+        </p:spPr>
+        <p:txBody>
+          <a:bodyPr wrap="none" lIns="27432">
+            <a:spAutoFit/>
+          </a:bodyPr>
+          <a:lstStyle/>
+          <a:p>
+            <a:pPr algn="r"/>
+            <a:r>
+              <a:rPr sz="800" b="0">
+                <a:solidFill>
+                  <a:srgbClr val="94A3B8"/>
+                </a:solidFill>
+                <a:latin typeface="Aptos"/>
+              </a:rPr>
+              <a:t>22</a:t>
+            </a:r>
+          </a:p>
+        </p:txBody>
+      </p:sp>
+    </p:spTree>
+  </p:cSld>
+  <p:clrMapOvr>
+    <a:masterClrMapping/>
+  </p:clrMapOvr>
+</p:sld>
+</file>
+
 <file path=ppt/slides/slide3.xml><?xml version="1.0" encoding="utf-8"?>
 <p:sld xmlns:a="http://schemas.openxmlformats.org/drawingml/2006/main" xmlns:r="http://schemas.openxmlformats.org/officeDocument/2006/relationships" xmlns:mc="http://schemas.openxmlformats.org/markup-compatibility/2006" xmlns:mv="urn:schemas-microsoft-com:mac:vml" xmlns:p="http://schemas.openxmlformats.org/presentationml/2006/main" xmlns:c="http://schemas.openxmlformats.org/drawingml/2006/chart" xmlns:dgm="http://schemas.openxmlformats.org/drawingml/2006/diagram" xmlns:o="urn:schemas-microsoft-com:office:office" xmlns:v="urn:schemas-microsoft-com:vml" xmlns:pvml="urn:schemas-microsoft-com:office:powerpoint" xmlns:com="http://schemas.openxmlformats.org/drawingml/2006/compatibility" xmlns:p14="http://schemas.microsoft.com/office/powerpoint/2010/main" xmlns:p15="http://schemas.microsoft.com/office/powerpoint/2012/main" xmlns:ahyp="http://schemas.microsoft.com/office/drawing/2018/hyperlinkcolor">
   <p:cSld>

</xml_diff>

<commit_message>
Add recent screening and steering audit to presentation
</commit_message>
<xml_diff>
--- a/MODEL DIFFS.pptx
+++ b/MODEL DIFFS.pptx
@@ -30,6 +30,13 @@
     <p:sldId id="275" r:id="rId26"/>
     <p:sldId id="276" r:id="rId27"/>
     <p:sldId id="277" r:id="rId28"/>
+    <p:sldId id="278" r:id="rId29"/>
+    <p:sldId id="279" r:id="rId30"/>
+    <p:sldId id="280" r:id="rId31"/>
+    <p:sldId id="281" r:id="rId32"/>
+    <p:sldId id="282" r:id="rId33"/>
+    <p:sldId id="283" r:id="rId34"/>
+    <p:sldId id="284" r:id="rId35"/>
   </p:sldIdLst>
   <p:sldSz cy="6858000" cx="12191675"/>
   <p:notesSz cx="6858000" cy="9144000"/>
@@ -28453,6 +28460,419 @@
 </p:sld>
 </file>
 
+<file path=ppt/slides/slide23.xml><?xml version="1.0" encoding="utf-8"?>
+<p:sld xmlns:a="http://schemas.openxmlformats.org/drawingml/2006/main" xmlns:p="http://schemas.openxmlformats.org/presentationml/2006/main" xmlns:r="http://schemas.openxmlformats.org/officeDocument/2006/relationships">
+  <p:cSld>
+    <p:spTree>
+      <p:nvGrpSpPr>
+        <p:cNvPr id="1" name=""/>
+        <p:cNvGrpSpPr/>
+        <p:nvPr/>
+      </p:nvGrpSpPr>
+      <p:grpSpPr/>
+      <p:sp>
+        <p:nvSpPr>
+          <p:cNvPr id="2" name="Title 1"/>
+          <p:cNvSpPr>
+            <a:spLocks noGrp="1"/>
+          </p:cNvSpPr>
+          <p:nvPr>
+            <p:ph type="title"/>
+          </p:nvPr>
+        </p:nvSpPr>
+        <p:spPr/>
+        <p:txBody>
+          <a:bodyPr/>
+          <a:lstStyle/>
+          <a:p/>
+        </p:txBody>
+      </p:sp>
+      <p:pic>
+        <p:nvPicPr>
+          <p:cNvPr id="3" name="Picture 2" descr="slide_23_eight_screens.png"/>
+          <p:cNvPicPr>
+            <a:picLocks noChangeAspect="1"/>
+          </p:cNvPicPr>
+          <p:nvPr/>
+        </p:nvPicPr>
+        <p:blipFill>
+          <a:blip r:embed="rId2"/>
+          <a:stretch>
+            <a:fillRect/>
+          </a:stretch>
+        </p:blipFill>
+        <p:spPr>
+          <a:xfrm>
+            <a:off x="0" y="0"/>
+            <a:ext cx="12191675" cy="6858000"/>
+          </a:xfrm>
+          <a:prstGeom prst="rect">
+            <a:avLst/>
+          </a:prstGeom>
+        </p:spPr>
+      </p:pic>
+    </p:spTree>
+  </p:cSld>
+  <p:clrMapOvr>
+    <a:masterClrMapping/>
+  </p:clrMapOvr>
+</p:sld>
+</file>
+
+<file path=ppt/slides/slide24.xml><?xml version="1.0" encoding="utf-8"?>
+<p:sld xmlns:a="http://schemas.openxmlformats.org/drawingml/2006/main" xmlns:p="http://schemas.openxmlformats.org/presentationml/2006/main" xmlns:r="http://schemas.openxmlformats.org/officeDocument/2006/relationships">
+  <p:cSld>
+    <p:spTree>
+      <p:nvGrpSpPr>
+        <p:cNvPr id="1" name=""/>
+        <p:cNvGrpSpPr/>
+        <p:nvPr/>
+      </p:nvGrpSpPr>
+      <p:grpSpPr/>
+      <p:sp>
+        <p:nvSpPr>
+          <p:cNvPr id="2" name="Title 1"/>
+          <p:cNvSpPr>
+            <a:spLocks noGrp="1"/>
+          </p:cNvSpPr>
+          <p:nvPr>
+            <p:ph type="title"/>
+          </p:nvPr>
+        </p:nvSpPr>
+        <p:spPr/>
+        <p:txBody>
+          <a:bodyPr/>
+          <a:lstStyle/>
+          <a:p/>
+        </p:txBody>
+      </p:sp>
+      <p:pic>
+        <p:nvPicPr>
+          <p:cNvPr id="3" name="Picture 2" descr="slide_24_alpha3_sweep.png"/>
+          <p:cNvPicPr>
+            <a:picLocks noChangeAspect="1"/>
+          </p:cNvPicPr>
+          <p:nvPr/>
+        </p:nvPicPr>
+        <p:blipFill>
+          <a:blip r:embed="rId2"/>
+          <a:stretch>
+            <a:fillRect/>
+          </a:stretch>
+        </p:blipFill>
+        <p:spPr>
+          <a:xfrm>
+            <a:off x="0" y="0"/>
+            <a:ext cx="12191675" cy="6858000"/>
+          </a:xfrm>
+          <a:prstGeom prst="rect">
+            <a:avLst/>
+          </a:prstGeom>
+        </p:spPr>
+      </p:pic>
+    </p:spTree>
+  </p:cSld>
+  <p:clrMapOvr>
+    <a:masterClrMapping/>
+  </p:clrMapOvr>
+</p:sld>
+</file>
+
+<file path=ppt/slides/slide25.xml><?xml version="1.0" encoding="utf-8"?>
+<p:sld xmlns:a="http://schemas.openxmlformats.org/drawingml/2006/main" xmlns:p="http://schemas.openxmlformats.org/presentationml/2006/main" xmlns:r="http://schemas.openxmlformats.org/officeDocument/2006/relationships">
+  <p:cSld>
+    <p:spTree>
+      <p:nvGrpSpPr>
+        <p:cNvPr id="1" name=""/>
+        <p:cNvGrpSpPr/>
+        <p:nvPr/>
+      </p:nvGrpSpPr>
+      <p:grpSpPr/>
+      <p:sp>
+        <p:nvSpPr>
+          <p:cNvPr id="2" name="Title 1"/>
+          <p:cNvSpPr>
+            <a:spLocks noGrp="1"/>
+          </p:cNvSpPr>
+          <p:nvPr>
+            <p:ph type="title"/>
+          </p:nvPr>
+        </p:nvSpPr>
+        <p:spPr/>
+        <p:txBody>
+          <a:bodyPr/>
+          <a:lstStyle/>
+          <a:p/>
+        </p:txBody>
+      </p:sp>
+      <p:pic>
+        <p:nvPicPr>
+          <p:cNvPr id="3" name="Picture 2" descr="slide_25_semantics.png"/>
+          <p:cNvPicPr>
+            <a:picLocks noChangeAspect="1"/>
+          </p:cNvPicPr>
+          <p:nvPr/>
+        </p:nvPicPr>
+        <p:blipFill>
+          <a:blip r:embed="rId2"/>
+          <a:stretch>
+            <a:fillRect/>
+          </a:stretch>
+        </p:blipFill>
+        <p:spPr>
+          <a:xfrm>
+            <a:off x="0" y="0"/>
+            <a:ext cx="12191675" cy="6858000"/>
+          </a:xfrm>
+          <a:prstGeom prst="rect">
+            <a:avLst/>
+          </a:prstGeom>
+        </p:spPr>
+      </p:pic>
+    </p:spTree>
+  </p:cSld>
+  <p:clrMapOvr>
+    <a:masterClrMapping/>
+  </p:clrMapOvr>
+</p:sld>
+</file>
+
+<file path=ppt/slides/slide26.xml><?xml version="1.0" encoding="utf-8"?>
+<p:sld xmlns:a="http://schemas.openxmlformats.org/drawingml/2006/main" xmlns:p="http://schemas.openxmlformats.org/presentationml/2006/main" xmlns:r="http://schemas.openxmlformats.org/officeDocument/2006/relationships">
+  <p:cSld>
+    <p:spTree>
+      <p:nvGrpSpPr>
+        <p:cNvPr id="1" name=""/>
+        <p:cNvGrpSpPr/>
+        <p:nvPr/>
+      </p:nvGrpSpPr>
+      <p:grpSpPr/>
+      <p:sp>
+        <p:nvSpPr>
+          <p:cNvPr id="2" name="Title 1"/>
+          <p:cNvSpPr>
+            <a:spLocks noGrp="1"/>
+          </p:cNvSpPr>
+          <p:nvPr>
+            <p:ph type="title"/>
+          </p:nvPr>
+        </p:nvSpPr>
+        <p:spPr/>
+        <p:txBody>
+          <a:bodyPr/>
+          <a:lstStyle/>
+          <a:p/>
+        </p:txBody>
+      </p:sp>
+      <p:pic>
+        <p:nvPicPr>
+          <p:cNvPr id="3" name="Picture 2" descr="slide_26_f3048_controls.png"/>
+          <p:cNvPicPr>
+            <a:picLocks noChangeAspect="1"/>
+          </p:cNvPicPr>
+          <p:nvPr/>
+        </p:nvPicPr>
+        <p:blipFill>
+          <a:blip r:embed="rId2"/>
+          <a:stretch>
+            <a:fillRect/>
+          </a:stretch>
+        </p:blipFill>
+        <p:spPr>
+          <a:xfrm>
+            <a:off x="0" y="0"/>
+            <a:ext cx="12191675" cy="6858000"/>
+          </a:xfrm>
+          <a:prstGeom prst="rect">
+            <a:avLst/>
+          </a:prstGeom>
+        </p:spPr>
+      </p:pic>
+    </p:spTree>
+  </p:cSld>
+  <p:clrMapOvr>
+    <a:masterClrMapping/>
+  </p:clrMapOvr>
+</p:sld>
+</file>
+
+<file path=ppt/slides/slide27.xml><?xml version="1.0" encoding="utf-8"?>
+<p:sld xmlns:a="http://schemas.openxmlformats.org/drawingml/2006/main" xmlns:p="http://schemas.openxmlformats.org/presentationml/2006/main" xmlns:r="http://schemas.openxmlformats.org/officeDocument/2006/relationships">
+  <p:cSld>
+    <p:spTree>
+      <p:nvGrpSpPr>
+        <p:cNvPr id="1" name=""/>
+        <p:cNvGrpSpPr/>
+        <p:nvPr/>
+      </p:nvGrpSpPr>
+      <p:grpSpPr/>
+      <p:sp>
+        <p:nvSpPr>
+          <p:cNvPr id="2" name="Title 1"/>
+          <p:cNvSpPr>
+            <a:spLocks noGrp="1"/>
+          </p:cNvSpPr>
+          <p:nvPr>
+            <p:ph type="title"/>
+          </p:nvPr>
+        </p:nvSpPr>
+        <p:spPr/>
+        <p:txBody>
+          <a:bodyPr/>
+          <a:lstStyle/>
+          <a:p/>
+        </p:txBody>
+      </p:sp>
+      <p:pic>
+        <p:nvPicPr>
+          <p:cNvPr id="3" name="Picture 2" descr="slide_27_f13147_controls.png"/>
+          <p:cNvPicPr>
+            <a:picLocks noChangeAspect="1"/>
+          </p:cNvPicPr>
+          <p:nvPr/>
+        </p:nvPicPr>
+        <p:blipFill>
+          <a:blip r:embed="rId2"/>
+          <a:stretch>
+            <a:fillRect/>
+          </a:stretch>
+        </p:blipFill>
+        <p:spPr>
+          <a:xfrm>
+            <a:off x="0" y="0"/>
+            <a:ext cx="12191675" cy="6858000"/>
+          </a:xfrm>
+          <a:prstGeom prst="rect">
+            <a:avLst/>
+          </a:prstGeom>
+        </p:spPr>
+      </p:pic>
+    </p:spTree>
+  </p:cSld>
+  <p:clrMapOvr>
+    <a:masterClrMapping/>
+  </p:clrMapOvr>
+</p:sld>
+</file>
+
+<file path=ppt/slides/slide28.xml><?xml version="1.0" encoding="utf-8"?>
+<p:sld xmlns:a="http://schemas.openxmlformats.org/drawingml/2006/main" xmlns:p="http://schemas.openxmlformats.org/presentationml/2006/main" xmlns:r="http://schemas.openxmlformats.org/officeDocument/2006/relationships">
+  <p:cSld>
+    <p:spTree>
+      <p:nvGrpSpPr>
+        <p:cNvPr id="1" name=""/>
+        <p:cNvGrpSpPr/>
+        <p:nvPr/>
+      </p:nvGrpSpPr>
+      <p:grpSpPr/>
+      <p:sp>
+        <p:nvSpPr>
+          <p:cNvPr id="2" name="Title 1"/>
+          <p:cNvSpPr>
+            <a:spLocks noGrp="1"/>
+          </p:cNvSpPr>
+          <p:nvPr>
+            <p:ph type="title"/>
+          </p:nvPr>
+        </p:nvSpPr>
+        <p:spPr/>
+        <p:txBody>
+          <a:bodyPr/>
+          <a:lstStyle/>
+          <a:p/>
+        </p:txBody>
+      </p:sp>
+      <p:pic>
+        <p:nvPicPr>
+          <p:cNvPr id="3" name="Picture 2" descr="slide_28_change_taxonomy.png"/>
+          <p:cNvPicPr>
+            <a:picLocks noChangeAspect="1"/>
+          </p:cNvPicPr>
+          <p:nvPr/>
+        </p:nvPicPr>
+        <p:blipFill>
+          <a:blip r:embed="rId2"/>
+          <a:stretch>
+            <a:fillRect/>
+          </a:stretch>
+        </p:blipFill>
+        <p:spPr>
+          <a:xfrm>
+            <a:off x="0" y="0"/>
+            <a:ext cx="12191675" cy="6858000"/>
+          </a:xfrm>
+          <a:prstGeom prst="rect">
+            <a:avLst/>
+          </a:prstGeom>
+        </p:spPr>
+      </p:pic>
+    </p:spTree>
+  </p:cSld>
+  <p:clrMapOvr>
+    <a:masterClrMapping/>
+  </p:clrMapOvr>
+</p:sld>
+</file>
+
+<file path=ppt/slides/slide29.xml><?xml version="1.0" encoding="utf-8"?>
+<p:sld xmlns:a="http://schemas.openxmlformats.org/drawingml/2006/main" xmlns:p="http://schemas.openxmlformats.org/presentationml/2006/main" xmlns:r="http://schemas.openxmlformats.org/officeDocument/2006/relationships">
+  <p:cSld>
+    <p:spTree>
+      <p:nvGrpSpPr>
+        <p:cNvPr id="1" name=""/>
+        <p:cNvGrpSpPr/>
+        <p:nvPr/>
+      </p:nvGrpSpPr>
+      <p:grpSpPr/>
+      <p:sp>
+        <p:nvSpPr>
+          <p:cNvPr id="2" name="Title 1"/>
+          <p:cNvSpPr>
+            <a:spLocks noGrp="1"/>
+          </p:cNvSpPr>
+          <p:nvPr>
+            <p:ph type="title"/>
+          </p:nvPr>
+        </p:nvSpPr>
+        <p:spPr/>
+        <p:txBody>
+          <a:bodyPr/>
+          <a:lstStyle/>
+          <a:p/>
+        </p:txBody>
+      </p:sp>
+      <p:pic>
+        <p:nvPicPr>
+          <p:cNvPr id="3" name="Picture 2" descr="slide_29_revised_claims.png"/>
+          <p:cNvPicPr>
+            <a:picLocks noChangeAspect="1"/>
+          </p:cNvPicPr>
+          <p:nvPr/>
+        </p:nvPicPr>
+        <p:blipFill>
+          <a:blip r:embed="rId2"/>
+          <a:stretch>
+            <a:fillRect/>
+          </a:stretch>
+        </p:blipFill>
+        <p:spPr>
+          <a:xfrm>
+            <a:off x="0" y="0"/>
+            <a:ext cx="12191675" cy="6858000"/>
+          </a:xfrm>
+          <a:prstGeom prst="rect">
+            <a:avLst/>
+          </a:prstGeom>
+        </p:spPr>
+      </p:pic>
+    </p:spTree>
+  </p:cSld>
+  <p:clrMapOvr>
+    <a:masterClrMapping/>
+  </p:clrMapOvr>
+</p:sld>
+</file>
+
 <file path=ppt/slides/slide3.xml><?xml version="1.0" encoding="utf-8"?>
 <p:sld xmlns:a="http://schemas.openxmlformats.org/drawingml/2006/main" xmlns:r="http://schemas.openxmlformats.org/officeDocument/2006/relationships" xmlns:mc="http://schemas.openxmlformats.org/markup-compatibility/2006" xmlns:mv="urn:schemas-microsoft-com:mac:vml" xmlns:p="http://schemas.openxmlformats.org/presentationml/2006/main" xmlns:c="http://schemas.openxmlformats.org/drawingml/2006/chart" xmlns:dgm="http://schemas.openxmlformats.org/drawingml/2006/diagram" xmlns:o="urn:schemas-microsoft-com:office:office" xmlns:v="urn:schemas-microsoft-com:vml" xmlns:pvml="urn:schemas-microsoft-com:office:powerpoint" xmlns:com="http://schemas.openxmlformats.org/drawingml/2006/compatibility" xmlns:p14="http://schemas.microsoft.com/office/powerpoint/2010/main" xmlns:p15="http://schemas.microsoft.com/office/powerpoint/2012/main" xmlns:ahyp="http://schemas.microsoft.com/office/drawing/2018/hyperlinkcolor">
   <p:cSld>

</xml_diff>